<commit_message>
Empty workspace by default — bring-your-own-data
Remove bundled sample datasets; a new user starts with an empty dashboard and
must upload a CSV/Parquet (or connect Elastic) before the agent runs. Add
no-data handling across DataPort, the orchestrator (idle loop + run_cycle
guard), endpoints, and the UI (empty-state dataset card, gated mission, empty
dataset dropdown). Update README, pitch script, and deck to the BYO-data story.
</commit_message>
<xml_diff>
--- a/docs/Epiphany_Pitch.pptx
+++ b/docs/Epiphany_Pitch.pptx
@@ -4572,7 +4572,7 @@
                 </a:solidFill>
                 <a:latin typeface="Calibri"/>
               </a:rPr>
-              <a:t>Upload any CSV — it adapts the test and the model</a:t>
+              <a:t>Bring any CSV — it adapts the test and the model</a:t>
             </a:r>
           </a:p>
         </p:txBody>
@@ -4586,7 +4586,7 @@
         <p:spPr>
           <a:xfrm>
             <a:off x="640080" y="2468880"/>
-            <a:ext cx="2926079" cy="548640"/>
+            <a:ext cx="5029200" cy="566928"/>
           </a:xfrm>
           <a:prstGeom prst="roundRect">
             <a:avLst/>
@@ -4630,8 +4630,8 @@
         </p:nvSpPr>
         <p:spPr>
           <a:xfrm>
-            <a:off x="749808" y="2523744"/>
-            <a:ext cx="2834639" cy="548640"/>
+            <a:off x="768096" y="2542032"/>
+            <a:ext cx="4892040" cy="548640"/>
           </a:xfrm>
           <a:prstGeom prst="rect">
             <a:avLst/>
@@ -4650,13 +4650,13 @@
               </a:spcAft>
             </a:pPr>
             <a:r>
-              <a:rPr sz="1400" b="1">
+              <a:rPr sz="1500" b="1">
                 <a:solidFill>
                   <a:srgbClr val="818CF8"/>
                 </a:solidFill>
                 <a:latin typeface="Calibri"/>
               </a:rPr>
-              <a:t>Dataset</a:t>
+              <a:t>If your target is…</a:t>
             </a:r>
           </a:p>
         </p:txBody>
@@ -4669,8 +4669,8 @@
         </p:nvSpPr>
         <p:spPr>
           <a:xfrm>
-            <a:off x="3657600" y="2468880"/>
-            <a:ext cx="2651760" cy="548640"/>
+            <a:off x="5760720" y="2468880"/>
+            <a:ext cx="5760720" cy="566928"/>
           </a:xfrm>
           <a:prstGeom prst="roundRect">
             <a:avLst/>
@@ -4714,8 +4714,8 @@
         </p:nvSpPr>
         <p:spPr>
           <a:xfrm>
-            <a:off x="3767328" y="2523744"/>
-            <a:ext cx="2560320" cy="548640"/>
+            <a:off x="5888736" y="2542032"/>
+            <a:ext cx="5623560" cy="548640"/>
           </a:xfrm>
           <a:prstGeom prst="rect">
             <a:avLst/>
@@ -4734,72 +4734,27 @@
               </a:spcAft>
             </a:pPr>
             <a:r>
-              <a:rPr sz="1400" b="1">
+              <a:rPr sz="1500" b="1">
                 <a:solidFill>
                   <a:srgbClr val="818CF8"/>
                 </a:solidFill>
                 <a:latin typeface="Calibri"/>
               </a:rPr>
-              <a:t>Domain</a:t>
-            </a:r>
-          </a:p>
-        </p:txBody>
-      </p:sp>
-      <p:sp>
-        <p:nvSpPr>
-          <p:cNvPr id="8" name="Rounded Rectangle 7"/>
-          <p:cNvSpPr/>
-          <p:nvPr/>
-        </p:nvSpPr>
-        <p:spPr>
-          <a:xfrm>
-            <a:off x="6400800" y="2468880"/>
-            <a:ext cx="2834640" cy="548640"/>
-          </a:xfrm>
-          <a:prstGeom prst="roundRect">
-            <a:avLst/>
-          </a:prstGeom>
-          <a:solidFill>
-            <a:srgbClr val="1E293B"/>
-          </a:solidFill>
-          <a:ln w="12700">
-            <a:solidFill>
-              <a:srgbClr val="2A3348"/>
-            </a:solidFill>
-          </a:ln>
-        </p:spPr>
-        <p:style>
-          <a:lnRef idx="1">
-            <a:schemeClr val="accent1"/>
-          </a:lnRef>
-          <a:fillRef idx="3">
-            <a:schemeClr val="accent1"/>
-          </a:fillRef>
-          <a:effectRef idx="2">
-            <a:schemeClr val="accent1"/>
-          </a:effectRef>
-          <a:fontRef idx="minor">
-            <a:schemeClr val="lt1"/>
-          </a:fontRef>
-        </p:style>
-        <p:txBody>
-          <a:bodyPr rtlCol="0" anchor="ctr"/>
-          <a:lstStyle/>
-          <a:p>
-            <a:pPr algn="ctr"/>
-          </a:p>
-        </p:txBody>
-      </p:sp>
-      <p:sp>
-        <p:nvSpPr>
-          <p:cNvPr id="9" name="TextBox 8"/>
+              <a:t>…Epiphany automatically picks</a:t>
+            </a:r>
+          </a:p>
+        </p:txBody>
+      </p:sp>
+      <p:sp>
+        <p:nvSpPr>
+          <p:cNvPr id="8" name="TextBox 7"/>
           <p:cNvSpPr txBox="1"/>
           <p:nvPr/>
         </p:nvSpPr>
         <p:spPr>
           <a:xfrm>
-            <a:off x="6510528" y="2523744"/>
-            <a:ext cx="2743200" cy="548640"/>
+            <a:off x="768096" y="3255264"/>
+            <a:ext cx="4892040" cy="548640"/>
           </a:xfrm>
           <a:prstGeom prst="rect">
             <a:avLst/>
@@ -4818,72 +4773,27 @@
               </a:spcAft>
             </a:pPr>
             <a:r>
-              <a:rPr sz="1400" b="1">
-                <a:solidFill>
-                  <a:srgbClr val="818CF8"/>
-                </a:solidFill>
-                <a:latin typeface="Calibri"/>
-              </a:rPr>
-              <a:t>Target</a:t>
-            </a:r>
-          </a:p>
-        </p:txBody>
-      </p:sp>
-      <p:sp>
-        <p:nvSpPr>
-          <p:cNvPr id="10" name="Rounded Rectangle 9"/>
-          <p:cNvSpPr/>
-          <p:nvPr/>
-        </p:nvSpPr>
-        <p:spPr>
-          <a:xfrm>
-            <a:off x="9326880" y="2468880"/>
-            <a:ext cx="3108960" cy="548640"/>
-          </a:xfrm>
-          <a:prstGeom prst="roundRect">
-            <a:avLst/>
-          </a:prstGeom>
-          <a:solidFill>
-            <a:srgbClr val="1E293B"/>
-          </a:solidFill>
-          <a:ln w="12700">
-            <a:solidFill>
-              <a:srgbClr val="2A3348"/>
-            </a:solidFill>
-          </a:ln>
-        </p:spPr>
-        <p:style>
-          <a:lnRef idx="1">
-            <a:schemeClr val="accent1"/>
-          </a:lnRef>
-          <a:fillRef idx="3">
-            <a:schemeClr val="accent1"/>
-          </a:fillRef>
-          <a:effectRef idx="2">
-            <a:schemeClr val="accent1"/>
-          </a:effectRef>
-          <a:fontRef idx="minor">
-            <a:schemeClr val="lt1"/>
-          </a:fontRef>
-        </p:style>
-        <p:txBody>
-          <a:bodyPr rtlCol="0" anchor="ctr"/>
-          <a:lstStyle/>
-          <a:p>
-            <a:pPr algn="ctr"/>
-          </a:p>
-        </p:txBody>
-      </p:sp>
-      <p:sp>
-        <p:nvSpPr>
-          <p:cNvPr id="11" name="TextBox 10"/>
+              <a:rPr sz="1500" b="0">
+                <a:solidFill>
+                  <a:srgbClr val="F8FAFC"/>
+                </a:solidFill>
+                <a:latin typeface="Calibri"/>
+              </a:rPr>
+              <a:t>a 2-class label (e.g. converted)</a:t>
+            </a:r>
+          </a:p>
+        </p:txBody>
+      </p:sp>
+      <p:sp>
+        <p:nvSpPr>
+          <p:cNvPr id="9" name="TextBox 8"/>
           <p:cNvSpPr txBox="1"/>
           <p:nvPr/>
         </p:nvSpPr>
         <p:spPr>
           <a:xfrm>
-            <a:off x="9436607" y="2523744"/>
-            <a:ext cx="3017520" cy="548640"/>
+            <a:off x="5888736" y="3255264"/>
+            <a:ext cx="5623560" cy="548640"/>
           </a:xfrm>
           <a:prstGeom prst="rect">
             <a:avLst/>
@@ -4902,27 +4812,27 @@
               </a:spcAft>
             </a:pPr>
             <a:r>
-              <a:rPr sz="1400" b="1">
-                <a:solidFill>
-                  <a:srgbClr val="818CF8"/>
-                </a:solidFill>
-                <a:latin typeface="Calibri"/>
-              </a:rPr>
-              <a:t>Test → Model</a:t>
-            </a:r>
-          </a:p>
-        </p:txBody>
-      </p:sp>
-      <p:sp>
-        <p:nvSpPr>
-          <p:cNvPr id="12" name="TextBox 11"/>
+              <a:rPr sz="1500" b="0">
+                <a:solidFill>
+                  <a:srgbClr val="F8FAFC"/>
+                </a:solidFill>
+                <a:latin typeface="Calibri"/>
+              </a:rPr>
+              <a:t>Welch's t-test  →  classifier</a:t>
+            </a:r>
+          </a:p>
+        </p:txBody>
+      </p:sp>
+      <p:sp>
+        <p:nvSpPr>
+          <p:cNvPr id="10" name="TextBox 9"/>
           <p:cNvSpPr txBox="1"/>
           <p:nvPr/>
         </p:nvSpPr>
         <p:spPr>
           <a:xfrm>
-            <a:off x="749808" y="3182112"/>
-            <a:ext cx="2834639" cy="548640"/>
+            <a:off x="768096" y="3968496"/>
+            <a:ext cx="4892040" cy="548640"/>
           </a:xfrm>
           <a:prstGeom prst="rect">
             <a:avLst/>
@@ -4941,27 +4851,27 @@
               </a:spcAft>
             </a:pPr>
             <a:r>
-              <a:rPr sz="1400" b="0">
+              <a:rPr sz="1500" b="0">
                 <a:solidFill>
                   <a:srgbClr val="F8FAFC"/>
                 </a:solidFill>
                 <a:latin typeface="Calibri"/>
               </a:rPr>
-              <a:t>train.csv</a:t>
-            </a:r>
-          </a:p>
-        </p:txBody>
-      </p:sp>
-      <p:sp>
-        <p:nvSpPr>
-          <p:cNvPr id="13" name="TextBox 12"/>
+              <a:t>a 3+-class category (e.g. tier)</a:t>
+            </a:r>
+          </a:p>
+        </p:txBody>
+      </p:sp>
+      <p:sp>
+        <p:nvSpPr>
+          <p:cNvPr id="11" name="TextBox 10"/>
           <p:cNvSpPr txBox="1"/>
           <p:nvPr/>
         </p:nvSpPr>
         <p:spPr>
           <a:xfrm>
-            <a:off x="3767328" y="3182112"/>
-            <a:ext cx="2560320" cy="548640"/>
+            <a:off x="5888736" y="3968496"/>
+            <a:ext cx="5623560" cy="548640"/>
           </a:xfrm>
           <a:prstGeom prst="rect">
             <a:avLst/>
@@ -4980,27 +4890,27 @@
               </a:spcAft>
             </a:pPr>
             <a:r>
-              <a:rPr sz="1400" b="0">
+              <a:rPr sz="1500" b="0">
                 <a:solidFill>
                   <a:srgbClr val="F8FAFC"/>
                 </a:solidFill>
                 <a:latin typeface="Calibri"/>
               </a:rPr>
-              <a:t>SaaS customers</a:t>
-            </a:r>
-          </a:p>
-        </p:txBody>
-      </p:sp>
-      <p:sp>
-        <p:nvSpPr>
-          <p:cNvPr id="14" name="TextBox 13"/>
+              <a:t>one-way ANOVA  →  classifier</a:t>
+            </a:r>
+          </a:p>
+        </p:txBody>
+      </p:sp>
+      <p:sp>
+        <p:nvSpPr>
+          <p:cNvPr id="12" name="TextBox 11"/>
           <p:cNvSpPr txBox="1"/>
           <p:nvPr/>
         </p:nvSpPr>
         <p:spPr>
           <a:xfrm>
-            <a:off x="6510528" y="3182112"/>
-            <a:ext cx="2743200" cy="548640"/>
+            <a:off x="768096" y="4681728"/>
+            <a:ext cx="4892040" cy="548640"/>
           </a:xfrm>
           <a:prstGeom prst="rect">
             <a:avLst/>
@@ -5019,27 +4929,27 @@
               </a:spcAft>
             </a:pPr>
             <a:r>
-              <a:rPr sz="1400" b="0">
+              <a:rPr sz="1500" b="0">
                 <a:solidFill>
                   <a:srgbClr val="F8FAFC"/>
                 </a:solidFill>
                 <a:latin typeface="Calibri"/>
               </a:rPr>
-              <a:t>Churn (binary)</a:t>
-            </a:r>
-          </a:p>
-        </p:txBody>
-      </p:sp>
-      <p:sp>
-        <p:nvSpPr>
-          <p:cNvPr id="15" name="TextBox 14"/>
+              <a:t>a continuous number (e.g. price)</a:t>
+            </a:r>
+          </a:p>
+        </p:txBody>
+      </p:sp>
+      <p:sp>
+        <p:nvSpPr>
+          <p:cNvPr id="13" name="TextBox 12"/>
           <p:cNvSpPr txBox="1"/>
           <p:nvPr/>
         </p:nvSpPr>
         <p:spPr>
           <a:xfrm>
-            <a:off x="9436607" y="3182112"/>
-            <a:ext cx="3017520" cy="548640"/>
+            <a:off x="5888736" y="4681728"/>
+            <a:ext cx="5623560" cy="548640"/>
           </a:xfrm>
           <a:prstGeom prst="rect">
             <a:avLst/>
@@ -5058,27 +4968,27 @@
               </a:spcAft>
             </a:pPr>
             <a:r>
-              <a:rPr sz="1400" b="0">
+              <a:rPr sz="1500" b="0">
                 <a:solidFill>
                   <a:srgbClr val="F8FAFC"/>
                 </a:solidFill>
                 <a:latin typeface="Calibri"/>
               </a:rPr>
-              <a:t>t-test → classifier</a:t>
-            </a:r>
-          </a:p>
-        </p:txBody>
-      </p:sp>
-      <p:sp>
-        <p:nvSpPr>
-          <p:cNvPr id="16" name="TextBox 15"/>
+              <a:t>Pearson / Spearman  →  regression</a:t>
+            </a:r>
+          </a:p>
+        </p:txBody>
+      </p:sp>
+      <p:sp>
+        <p:nvSpPr>
+          <p:cNvPr id="14" name="TextBox 13"/>
           <p:cNvSpPr txBox="1"/>
           <p:nvPr/>
         </p:nvSpPr>
         <p:spPr>
           <a:xfrm>
-            <a:off x="749808" y="3840479"/>
-            <a:ext cx="2834639" cy="548640"/>
+            <a:off x="768096" y="5394960"/>
+            <a:ext cx="4892040" cy="548640"/>
           </a:xfrm>
           <a:prstGeom prst="rect">
             <a:avLst/>
@@ -5097,27 +5007,27 @@
               </a:spcAft>
             </a:pPr>
             <a:r>
-              <a:rPr sz="1400" b="0">
+              <a:rPr sz="1500" b="0">
                 <a:solidFill>
                   <a:srgbClr val="F8FAFC"/>
                 </a:solidFill>
                 <a:latin typeface="Calibri"/>
               </a:rPr>
-              <a:t>wine_cultivars.csv</a:t>
-            </a:r>
-          </a:p>
-        </p:txBody>
-      </p:sp>
-      <p:sp>
-        <p:nvSpPr>
-          <p:cNvPr id="17" name="TextBox 16"/>
+              <a:t>two categories (region × outcome)</a:t>
+            </a:r>
+          </a:p>
+        </p:txBody>
+      </p:sp>
+      <p:sp>
+        <p:nvSpPr>
+          <p:cNvPr id="15" name="TextBox 14"/>
           <p:cNvSpPr txBox="1"/>
           <p:nvPr/>
         </p:nvSpPr>
         <p:spPr>
           <a:xfrm>
-            <a:off x="3767328" y="3840479"/>
-            <a:ext cx="2560320" cy="548640"/>
+            <a:off x="5888736" y="5394960"/>
+            <a:ext cx="5623560" cy="548640"/>
           </a:xfrm>
           <a:prstGeom prst="rect">
             <a:avLst/>
@@ -5136,27 +5046,27 @@
               </a:spcAft>
             </a:pPr>
             <a:r>
-              <a:rPr sz="1400" b="0">
+              <a:rPr sz="1500" b="0">
                 <a:solidFill>
                   <a:srgbClr val="F8FAFC"/>
                 </a:solidFill>
                 <a:latin typeface="Calibri"/>
               </a:rPr>
-              <a:t>Wine chemistry</a:t>
-            </a:r>
-          </a:p>
-        </p:txBody>
-      </p:sp>
-      <p:sp>
-        <p:nvSpPr>
-          <p:cNvPr id="18" name="TextBox 17"/>
+              <a:t>Chi-Square test of independence</a:t>
+            </a:r>
+          </a:p>
+        </p:txBody>
+      </p:sp>
+      <p:sp>
+        <p:nvSpPr>
+          <p:cNvPr id="16" name="TextBox 15"/>
           <p:cNvSpPr txBox="1"/>
           <p:nvPr/>
         </p:nvSpPr>
         <p:spPr>
           <a:xfrm>
-            <a:off x="6510528" y="3840479"/>
-            <a:ext cx="2743200" cy="548640"/>
+            <a:off x="640080" y="5852160"/>
+            <a:ext cx="10972800" cy="731520"/>
           </a:xfrm>
           <a:prstGeom prst="rect">
             <a:avLst/>
@@ -5175,247 +5085,13 @@
               </a:spcAft>
             </a:pPr>
             <a:r>
-              <a:rPr sz="1400" b="0">
-                <a:solidFill>
-                  <a:srgbClr val="F8FAFC"/>
-                </a:solidFill>
-                <a:latin typeface="Calibri"/>
-              </a:rPr>
-              <a:t>wine_class (3-class)</a:t>
-            </a:r>
-          </a:p>
-        </p:txBody>
-      </p:sp>
-      <p:sp>
-        <p:nvSpPr>
-          <p:cNvPr id="19" name="TextBox 18"/>
-          <p:cNvSpPr txBox="1"/>
-          <p:nvPr/>
-        </p:nvSpPr>
-        <p:spPr>
-          <a:xfrm>
-            <a:off x="9436607" y="3840479"/>
-            <a:ext cx="3017520" cy="548640"/>
-          </a:xfrm>
-          <a:prstGeom prst="rect">
-            <a:avLst/>
-          </a:prstGeom>
-          <a:noFill/>
-        </p:spPr>
-        <p:txBody>
-          <a:bodyPr wrap="square">
-            <a:spAutoFit/>
-          </a:bodyPr>
-          <a:lstStyle/>
-          <a:p>
-            <a:pPr>
-              <a:spcAft>
-                <a:spcPts val="1000"/>
-              </a:spcAft>
-            </a:pPr>
-            <a:r>
-              <a:rPr sz="1400" b="0">
-                <a:solidFill>
-                  <a:srgbClr val="F8FAFC"/>
-                </a:solidFill>
-                <a:latin typeface="Calibri"/>
-              </a:rPr>
-              <a:t>ANOVA → classifier (94%)</a:t>
-            </a:r>
-          </a:p>
-        </p:txBody>
-      </p:sp>
-      <p:sp>
-        <p:nvSpPr>
-          <p:cNvPr id="20" name="TextBox 19"/>
-          <p:cNvSpPr txBox="1"/>
-          <p:nvPr/>
-        </p:nvSpPr>
-        <p:spPr>
-          <a:xfrm>
-            <a:off x="749808" y="4498847"/>
-            <a:ext cx="2834639" cy="548640"/>
-          </a:xfrm>
-          <a:prstGeom prst="rect">
-            <a:avLst/>
-          </a:prstGeom>
-          <a:noFill/>
-        </p:spPr>
-        <p:txBody>
-          <a:bodyPr wrap="square">
-            <a:spAutoFit/>
-          </a:bodyPr>
-          <a:lstStyle/>
-          <a:p>
-            <a:pPr>
-              <a:spcAft>
-                <a:spcPts val="1000"/>
-              </a:spcAft>
-            </a:pPr>
-            <a:r>
-              <a:rPr sz="1400" b="0">
-                <a:solidFill>
-                  <a:srgbClr val="F8FAFC"/>
-                </a:solidFill>
-                <a:latin typeface="Calibri"/>
-              </a:rPr>
-              <a:t>diabetes_progression.csv</a:t>
-            </a:r>
-          </a:p>
-        </p:txBody>
-      </p:sp>
-      <p:sp>
-        <p:nvSpPr>
-          <p:cNvPr id="21" name="TextBox 20"/>
-          <p:cNvSpPr txBox="1"/>
-          <p:nvPr/>
-        </p:nvSpPr>
-        <p:spPr>
-          <a:xfrm>
-            <a:off x="3767328" y="4498847"/>
-            <a:ext cx="2560320" cy="548640"/>
-          </a:xfrm>
-          <a:prstGeom prst="rect">
-            <a:avLst/>
-          </a:prstGeom>
-          <a:noFill/>
-        </p:spPr>
-        <p:txBody>
-          <a:bodyPr wrap="square">
-            <a:spAutoFit/>
-          </a:bodyPr>
-          <a:lstStyle/>
-          <a:p>
-            <a:pPr>
-              <a:spcAft>
-                <a:spcPts val="1000"/>
-              </a:spcAft>
-            </a:pPr>
-            <a:r>
-              <a:rPr sz="1400" b="0">
-                <a:solidFill>
-                  <a:srgbClr val="F8FAFC"/>
-                </a:solidFill>
-                <a:latin typeface="Calibri"/>
-              </a:rPr>
-              <a:t>Healthcare</a:t>
-            </a:r>
-          </a:p>
-        </p:txBody>
-      </p:sp>
-      <p:sp>
-        <p:nvSpPr>
-          <p:cNvPr id="22" name="TextBox 21"/>
-          <p:cNvSpPr txBox="1"/>
-          <p:nvPr/>
-        </p:nvSpPr>
-        <p:spPr>
-          <a:xfrm>
-            <a:off x="6510528" y="4498847"/>
-            <a:ext cx="2743200" cy="548640"/>
-          </a:xfrm>
-          <a:prstGeom prst="rect">
-            <a:avLst/>
-          </a:prstGeom>
-          <a:noFill/>
-        </p:spPr>
-        <p:txBody>
-          <a:bodyPr wrap="square">
-            <a:spAutoFit/>
-          </a:bodyPr>
-          <a:lstStyle/>
-          <a:p>
-            <a:pPr>
-              <a:spcAft>
-                <a:spcPts val="1000"/>
-              </a:spcAft>
-            </a:pPr>
-            <a:r>
-              <a:rPr sz="1400" b="0">
-                <a:solidFill>
-                  <a:srgbClr val="F8FAFC"/>
-                </a:solidFill>
-                <a:latin typeface="Calibri"/>
-              </a:rPr>
-              <a:t>progression (numeric)</a:t>
-            </a:r>
-          </a:p>
-        </p:txBody>
-      </p:sp>
-      <p:sp>
-        <p:nvSpPr>
-          <p:cNvPr id="23" name="TextBox 22"/>
-          <p:cNvSpPr txBox="1"/>
-          <p:nvPr/>
-        </p:nvSpPr>
-        <p:spPr>
-          <a:xfrm>
-            <a:off x="9436607" y="4498847"/>
-            <a:ext cx="3017520" cy="548640"/>
-          </a:xfrm>
-          <a:prstGeom prst="rect">
-            <a:avLst/>
-          </a:prstGeom>
-          <a:noFill/>
-        </p:spPr>
-        <p:txBody>
-          <a:bodyPr wrap="square">
-            <a:spAutoFit/>
-          </a:bodyPr>
-          <a:lstStyle/>
-          <a:p>
-            <a:pPr>
-              <a:spcAft>
-                <a:spcPts val="1000"/>
-              </a:spcAft>
-            </a:pPr>
-            <a:r>
-              <a:rPr sz="1400" b="0">
-                <a:solidFill>
-                  <a:srgbClr val="F8FAFC"/>
-                </a:solidFill>
-                <a:latin typeface="Calibri"/>
-              </a:rPr>
-              <a:t>correlation → regression</a:t>
-            </a:r>
-          </a:p>
-        </p:txBody>
-      </p:sp>
-      <p:sp>
-        <p:nvSpPr>
-          <p:cNvPr id="24" name="TextBox 23"/>
-          <p:cNvSpPr txBox="1"/>
-          <p:nvPr/>
-        </p:nvSpPr>
-        <p:spPr>
-          <a:xfrm>
-            <a:off x="640080" y="5669280"/>
-            <a:ext cx="10972800" cy="731520"/>
-          </a:xfrm>
-          <a:prstGeom prst="rect">
-            <a:avLst/>
-          </a:prstGeom>
-          <a:noFill/>
-        </p:spPr>
-        <p:txBody>
-          <a:bodyPr wrap="square">
-            <a:spAutoFit/>
-          </a:bodyPr>
-          <a:lstStyle/>
-          <a:p>
-            <a:pPr>
-              <a:spcAft>
-                <a:spcPts val="1000"/>
-              </a:spcAft>
-            </a:pPr>
-            <a:r>
               <a:rPr sz="1500" b="1">
                 <a:solidFill>
                   <a:srgbClr val="10B981"/>
                 </a:solidFill>
                 <a:latin typeface="Calibri"/>
               </a:rPr>
-              <a:t>Same agent. Zero configuration. It picks the statistically correct method for whatever you give it.</a:t>
+              <a:t>No samples shipped — you upload your data and the agent auto-detects the target and the correct method.</a:t>
             </a:r>
           </a:p>
         </p:txBody>
@@ -5821,7 +5497,7 @@
                 </a:solidFill>
                 <a:latin typeface="Calibri"/>
               </a:rPr>
-              <a:t>•  1.  Sign in (Clerk) → the dashboard's Active Agent Stream is already working autonomously.</a:t>
+              <a:t>•  1.  Sign in (Clerk) → an empty workspace; upload a CSV to begin.</a:t>
             </a:r>
           </a:p>
           <a:p>
@@ -5837,7 +5513,7 @@
                 </a:solidFill>
                 <a:latin typeface="Calibri"/>
               </a:rPr>
-              <a:t>•  2.  Switch churn → wine: it re-profiles and now chooses ANOVA + a 94% classifier.</a:t>
+              <a:t>•  2.  The agent auto-detects the target and runs its loop live.</a:t>
             </a:r>
           </a:p>
           <a:p>
@@ -5853,7 +5529,7 @@
                 </a:solidFill>
                 <a:latin typeface="Calibri"/>
               </a:rPr>
-              <a:t>•  3.  Run a mission in plain English → Gemini + ADK pick the tools live.</a:t>
+              <a:t>•  3.  Upload a different dataset → it switches the statistical test automatically.</a:t>
             </a:r>
           </a:p>
           <a:p>
@@ -5869,7 +5545,7 @@
                 </a:solidFill>
                 <a:latin typeface="Calibri"/>
               </a:rPr>
-              <a:t>•  4.  Upload your own CSV → it works on your data too.</a:t>
+              <a:t>•  4.  Run a mission in plain English → Gemini + ADK pick the tools live.</a:t>
             </a:r>
           </a:p>
         </p:txBody>

</xml_diff>